<commit_message>
study: show precise pending-case percentages in executive slides
</commit_message>
<xml_diff>
--- a/presentations/Case_Retencao_Resultados_e_Descobertas_2025.pptx
+++ b/presentations/Case_Retencao_Resultados_e_Descobertas_2025.pptx
@@ -7354,7 +7354,7 @@
                 <a:ea typeface="Aptos" pitchFamily="34" charset="-122"/>
                 <a:cs typeface="Aptos" pitchFamily="34" charset="-120"/>
               </a:rPr>
-              <a:t>9,0%</a:t>
+              <a:t>9,01%</a:t>
             </a:r>
             <a:endParaRPr lang="en-US" sz="2200" dirty="0"/>
           </a:p>
@@ -7527,7 +7527,7 @@
                 <a:ea typeface="Aptos" pitchFamily="34" charset="-122"/>
                 <a:cs typeface="Aptos" pitchFamily="34" charset="-120"/>
               </a:rPr>
-              <a:t>0,0%</a:t>
+              <a:t>0,04%</a:t>
             </a:r>
             <a:endParaRPr lang="en-US" sz="2200" dirty="0"/>
           </a:p>

</xml_diff>

<commit_message>
study: deepen retention exploration and quantify uncertainty and scenarios
</commit_message>
<xml_diff>
--- a/presentations/Case_Retencao_Resultados_e_Descobertas_2025.pptx
+++ b/presentations/Case_Retencao_Resultados_e_Descobertas_2025.pptx
@@ -25,6 +25,11 @@
     <p:sldId id="273" r:id="rId19"/>
     <p:sldId id="274" r:id="rId20"/>
     <p:sldId id="275" r:id="rId21"/>
+    <p:sldId id="276" r:id="rId27"/>
+    <p:sldId id="277" r:id="rId28"/>
+    <p:sldId id="278" r:id="rId29"/>
+    <p:sldId id="279" r:id="rId30"/>
+    <p:sldId id="280" r:id="rId31"/>
   </p:sldIdLst>
   <p:notesMasterIdLst>
     <p:notesMasterId r:id="rId22"/>
@@ -13037,6 +13042,2273 @@
 </p:sld>
 </file>
 
+<file path=ppt/slides/slide21.xml><?xml version="1.0" encoding="utf-8"?>
+<p:sld xmlns:a="http://schemas.openxmlformats.org/drawingml/2006/main" xmlns:p="http://schemas.openxmlformats.org/presentationml/2006/main" xmlns:r="http://schemas.openxmlformats.org/officeDocument/2006/relationships">
+  <p:cSld>
+    <p:spTree>
+      <p:nvGrpSpPr>
+        <p:cNvPr id="1" name=""/>
+        <p:cNvGrpSpPr/>
+        <p:nvPr/>
+      </p:nvGrpSpPr>
+      <p:grpSpPr/>
+      <p:sp>
+        <p:nvSpPr>
+          <p:cNvPr id="2" name="TextBox 1"/>
+          <p:cNvSpPr txBox="1"/>
+          <p:nvPr/>
+        </p:nvSpPr>
+        <p:spPr>
+          <a:xfrm>
+            <a:off x="594360" y="274320"/>
+            <a:ext cx="8229600" cy="320040"/>
+          </a:xfrm>
+          <a:prstGeom prst="rect">
+            <a:avLst/>
+          </a:prstGeom>
+          <a:noFill/>
+        </p:spPr>
+        <p:txBody>
+          <a:bodyPr wrap="square">
+            <a:spAutoFit/>
+          </a:bodyPr>
+          <a:lstStyle/>
+          <a:p>
+            <a:pPr algn="l"/>
+            <a:r>
+              <a:rPr sz="1300" b="1">
+                <a:solidFill>
+                  <a:srgbClr val="285F5B"/>
+                </a:solidFill>
+                <a:latin typeface="Aptos"/>
+              </a:rPr>
+              <a:t>ESTUDO OBSERVACIONAL | JUN–DEZ 2025</a:t>
+            </a:r>
+          </a:p>
+        </p:txBody>
+      </p:sp>
+      <p:sp>
+        <p:nvSpPr>
+          <p:cNvPr id="3" name="TextBox 2"/>
+          <p:cNvSpPr txBox="1"/>
+          <p:nvPr/>
+        </p:nvSpPr>
+        <p:spPr>
+          <a:xfrm>
+            <a:off x="594360" y="685800"/>
+            <a:ext cx="11064240" cy="685800"/>
+          </a:xfrm>
+          <a:prstGeom prst="rect">
+            <a:avLst/>
+          </a:prstGeom>
+          <a:noFill/>
+        </p:spPr>
+        <p:txBody>
+          <a:bodyPr wrap="square">
+            <a:spAutoFit/>
+          </a:bodyPr>
+          <a:lstStyle/>
+          <a:p>
+            <a:pPr algn="l"/>
+            <a:r>
+              <a:rPr sz="3000" b="1">
+                <a:solidFill>
+                  <a:srgbClr val="132B33"/>
+                </a:solidFill>
+                <a:latin typeface="Aptos"/>
+              </a:rPr>
+              <a:t>Retidos: quatro resultados econômicos distintos</a:t>
+            </a:r>
+          </a:p>
+        </p:txBody>
+      </p:sp>
+      <p:sp>
+        <p:nvSpPr>
+          <p:cNvPr id="4" name="Rectangle 3"/>
+          <p:cNvSpPr/>
+          <p:nvPr/>
+        </p:nvSpPr>
+        <p:spPr>
+          <a:xfrm>
+            <a:off x="594360" y="1463040"/>
+            <a:ext cx="11018520" cy="25603"/>
+          </a:xfrm>
+          <a:prstGeom prst="rect">
+            <a:avLst/>
+          </a:prstGeom>
+          <a:solidFill>
+            <a:srgbClr val="B7914E"/>
+          </a:solidFill>
+          <a:ln>
+            <a:noFill/>
+          </a:ln>
+        </p:spPr>
+        <p:style>
+          <a:lnRef idx="1">
+            <a:schemeClr val="accent1"/>
+          </a:lnRef>
+          <a:fillRef idx="3">
+            <a:schemeClr val="accent1"/>
+          </a:fillRef>
+          <a:effectRef idx="2">
+            <a:schemeClr val="accent1"/>
+          </a:effectRef>
+          <a:fontRef idx="minor">
+            <a:schemeClr val="lt1"/>
+          </a:fontRef>
+        </p:style>
+        <p:txBody>
+          <a:bodyPr rtlCol="0" anchor="ctr"/>
+          <a:lstStyle/>
+          <a:p>
+            <a:pPr algn="ctr"/>
+          </a:p>
+        </p:txBody>
+      </p:sp>
+      <p:sp>
+        <p:nvSpPr>
+          <p:cNvPr id="5" name="TextBox 4"/>
+          <p:cNvSpPr txBox="1"/>
+          <p:nvPr/>
+        </p:nvSpPr>
+        <p:spPr>
+          <a:xfrm>
+            <a:off x="594360" y="6492240"/>
+            <a:ext cx="9144000" cy="228600"/>
+          </a:xfrm>
+          <a:prstGeom prst="rect">
+            <a:avLst/>
+          </a:prstGeom>
+          <a:noFill/>
+        </p:spPr>
+        <p:txBody>
+          <a:bodyPr wrap="square">
+            <a:spAutoFit/>
+          </a:bodyPr>
+          <a:lstStyle/>
+          <a:p>
+            <a:pPr algn="l"/>
+            <a:r>
+              <a:rPr sz="900" b="0">
+                <a:solidFill>
+                  <a:srgbClr val="54686B"/>
+                </a:solidFill>
+                <a:latin typeface="Aptos"/>
+              </a:rPr>
+              <a:t>REGISTROS DO FUNIL • DEFINIÇÕES PROVISÓRIAS • NÃO CAUSAL</a:t>
+            </a:r>
+          </a:p>
+        </p:txBody>
+      </p:sp>
+      <p:sp>
+        <p:nvSpPr>
+          <p:cNvPr id="6" name="TextBox 5"/>
+          <p:cNvSpPr txBox="1"/>
+          <p:nvPr/>
+        </p:nvSpPr>
+        <p:spPr>
+          <a:xfrm>
+            <a:off x="10972800" y="6455664"/>
+            <a:ext cx="731520" cy="274320"/>
+          </a:xfrm>
+          <a:prstGeom prst="rect">
+            <a:avLst/>
+          </a:prstGeom>
+          <a:noFill/>
+        </p:spPr>
+        <p:txBody>
+          <a:bodyPr wrap="square">
+            <a:spAutoFit/>
+          </a:bodyPr>
+          <a:lstStyle/>
+          <a:p>
+            <a:pPr algn="l"/>
+            <a:r>
+              <a:rPr sz="1100" b="1">
+                <a:solidFill>
+                  <a:srgbClr val="285F5B"/>
+                </a:solidFill>
+                <a:latin typeface="Aptos"/>
+              </a:rPr>
+              <a:t>21</a:t>
+            </a:r>
+          </a:p>
+        </p:txBody>
+      </p:sp>
+      <p:pic>
+        <p:nvPicPr>
+          <p:cNvPr id="7" name="Picture 6" descr="retained_four_event_economics.png"/>
+          <p:cNvPicPr>
+            <a:picLocks noChangeAspect="1"/>
+          </p:cNvPicPr>
+          <p:nvPr/>
+        </p:nvPicPr>
+        <p:blipFill>
+          <a:blip r:embed="rId2"/>
+          <a:stretch>
+            <a:fillRect/>
+          </a:stretch>
+        </p:blipFill>
+        <p:spPr>
+          <a:xfrm>
+            <a:off x="530352" y="1645920"/>
+            <a:ext cx="7955279" cy="3487064"/>
+          </a:xfrm>
+          <a:prstGeom prst="rect">
+            <a:avLst/>
+          </a:prstGeom>
+        </p:spPr>
+      </p:pic>
+      <p:sp>
+        <p:nvSpPr>
+          <p:cNvPr id="8" name="TextBox 7"/>
+          <p:cNvSpPr txBox="1"/>
+          <p:nvPr/>
+        </p:nvSpPr>
+        <p:spPr>
+          <a:xfrm>
+            <a:off x="8641080" y="2011680"/>
+            <a:ext cx="3017520" cy="594360"/>
+          </a:xfrm>
+          <a:prstGeom prst="rect">
+            <a:avLst/>
+          </a:prstGeom>
+          <a:noFill/>
+        </p:spPr>
+        <p:txBody>
+          <a:bodyPr wrap="square">
+            <a:spAutoFit/>
+          </a:bodyPr>
+          <a:lstStyle/>
+          <a:p>
+            <a:pPr algn="l"/>
+            <a:r>
+              <a:rPr sz="3500" b="1">
+                <a:solidFill>
+                  <a:srgbClr val="285F5B"/>
+                </a:solidFill>
+                <a:latin typeface="Aptos"/>
+              </a:rPr>
+              <a:t>32.318</a:t>
+            </a:r>
+          </a:p>
+        </p:txBody>
+      </p:sp>
+      <p:sp>
+        <p:nvSpPr>
+          <p:cNvPr id="9" name="TextBox 8"/>
+          <p:cNvSpPr txBox="1"/>
+          <p:nvPr/>
+        </p:nvSpPr>
+        <p:spPr>
+          <a:xfrm>
+            <a:off x="8641080" y="2624328"/>
+            <a:ext cx="2834640" cy="1097280"/>
+          </a:xfrm>
+          <a:prstGeom prst="rect">
+            <a:avLst/>
+          </a:prstGeom>
+          <a:noFill/>
+        </p:spPr>
+        <p:txBody>
+          <a:bodyPr wrap="square">
+            <a:spAutoFit/>
+          </a:bodyPr>
+          <a:lstStyle/>
+          <a:p>
+            <a:pPr algn="l"/>
+            <a:r>
+              <a:rPr sz="1700" b="0">
+                <a:solidFill>
+                  <a:srgbClr val="132B33"/>
+                </a:solidFill>
+                <a:latin typeface="Aptos"/>
+              </a:rPr>
+              <a:t>retidos sem movimentação, mas com cancelamento de produto</a:t>
+            </a:r>
+          </a:p>
+        </p:txBody>
+      </p:sp>
+      <p:sp>
+        <p:nvSpPr>
+          <p:cNvPr id="10" name="TextBox 9"/>
+          <p:cNvSpPr txBox="1"/>
+          <p:nvPr/>
+        </p:nvSpPr>
+        <p:spPr>
+          <a:xfrm>
+            <a:off x="8641080" y="3785615"/>
+            <a:ext cx="3017520" cy="530352"/>
+          </a:xfrm>
+          <a:prstGeom prst="rect">
+            <a:avLst/>
+          </a:prstGeom>
+          <a:noFill/>
+        </p:spPr>
+        <p:txBody>
+          <a:bodyPr wrap="square">
+            <a:spAutoFit/>
+          </a:bodyPr>
+          <a:lstStyle/>
+          <a:p>
+            <a:pPr algn="l"/>
+            <a:r>
+              <a:rPr sz="1800" b="1">
+                <a:solidFill>
+                  <a:srgbClr val="132B33"/>
+                </a:solidFill>
+                <a:latin typeface="Aptos"/>
+              </a:rPr>
+              <a:t>Mediana ΔV = −104,90</a:t>
+            </a:r>
+          </a:p>
+        </p:txBody>
+      </p:sp>
+      <p:sp>
+        <p:nvSpPr>
+          <p:cNvPr id="11" name="TextBox 10"/>
+          <p:cNvSpPr txBox="1"/>
+          <p:nvPr/>
+        </p:nvSpPr>
+        <p:spPr>
+          <a:xfrm>
+            <a:off x="8641080" y="4681728"/>
+            <a:ext cx="2788920" cy="1143000"/>
+          </a:xfrm>
+          <a:prstGeom prst="rect">
+            <a:avLst/>
+          </a:prstGeom>
+          <a:noFill/>
+        </p:spPr>
+        <p:txBody>
+          <a:bodyPr wrap="square">
+            <a:spAutoFit/>
+          </a:bodyPr>
+          <a:lstStyle/>
+          <a:p>
+            <a:pPr algn="l"/>
+            <a:r>
+              <a:rPr sz="1600" b="0">
+                <a:solidFill>
+                  <a:srgbClr val="54686B"/>
+                </a:solidFill>
+                <a:latin typeface="Aptos"/>
+              </a:rPr>
+              <a:t>O desfecho RETIDO não implica manutenção do mix nem dos valores observados.</a:t>
+            </a:r>
+          </a:p>
+        </p:txBody>
+      </p:sp>
+    </p:spTree>
+  </p:cSld>
+  <p:clrMapOvr>
+    <a:masterClrMapping/>
+  </p:clrMapOvr>
+</p:sld>
+</file>
+
+<file path=ppt/slides/slide22.xml><?xml version="1.0" encoding="utf-8"?>
+<p:sld xmlns:a="http://schemas.openxmlformats.org/drawingml/2006/main" xmlns:p="http://schemas.openxmlformats.org/presentationml/2006/main" xmlns:r="http://schemas.openxmlformats.org/officeDocument/2006/relationships">
+  <p:cSld>
+    <p:spTree>
+      <p:nvGrpSpPr>
+        <p:cNvPr id="1" name=""/>
+        <p:cNvGrpSpPr/>
+        <p:nvPr/>
+      </p:nvGrpSpPr>
+      <p:grpSpPr/>
+      <p:sp>
+        <p:nvSpPr>
+          <p:cNvPr id="2" name="TextBox 1"/>
+          <p:cNvSpPr txBox="1"/>
+          <p:nvPr/>
+        </p:nvSpPr>
+        <p:spPr>
+          <a:xfrm>
+            <a:off x="594360" y="274320"/>
+            <a:ext cx="8229600" cy="320040"/>
+          </a:xfrm>
+          <a:prstGeom prst="rect">
+            <a:avLst/>
+          </a:prstGeom>
+          <a:noFill/>
+        </p:spPr>
+        <p:txBody>
+          <a:bodyPr wrap="square">
+            <a:spAutoFit/>
+          </a:bodyPr>
+          <a:lstStyle/>
+          <a:p>
+            <a:pPr algn="l"/>
+            <a:r>
+              <a:rPr sz="1300" b="1">
+                <a:solidFill>
+                  <a:srgbClr val="285F5B"/>
+                </a:solidFill>
+                <a:latin typeface="Aptos"/>
+              </a:rPr>
+              <a:t>ESTUDO OBSERVACIONAL | JUN–DEZ 2025</a:t>
+            </a:r>
+          </a:p>
+        </p:txBody>
+      </p:sp>
+      <p:sp>
+        <p:nvSpPr>
+          <p:cNvPr id="3" name="TextBox 2"/>
+          <p:cNvSpPr txBox="1"/>
+          <p:nvPr/>
+        </p:nvSpPr>
+        <p:spPr>
+          <a:xfrm>
+            <a:off x="594360" y="685800"/>
+            <a:ext cx="11064240" cy="685800"/>
+          </a:xfrm>
+          <a:prstGeom prst="rect">
+            <a:avLst/>
+          </a:prstGeom>
+          <a:noFill/>
+        </p:spPr>
+        <p:txBody>
+          <a:bodyPr wrap="square">
+            <a:spAutoFit/>
+          </a:bodyPr>
+          <a:lstStyle/>
+          <a:p>
+            <a:pPr algn="l"/>
+            <a:r>
+              <a:rPr sz="3000" b="1">
+                <a:solidFill>
+                  <a:srgbClr val="132B33"/>
+                </a:solidFill>
+                <a:latin typeface="Aptos"/>
+              </a:rPr>
+              <a:t>Cancelamentos parciais e trocas de planos</a:t>
+            </a:r>
+          </a:p>
+        </p:txBody>
+      </p:sp>
+      <p:sp>
+        <p:nvSpPr>
+          <p:cNvPr id="4" name="Rectangle 3"/>
+          <p:cNvSpPr/>
+          <p:nvPr/>
+        </p:nvSpPr>
+        <p:spPr>
+          <a:xfrm>
+            <a:off x="594360" y="1463040"/>
+            <a:ext cx="11018520" cy="25603"/>
+          </a:xfrm>
+          <a:prstGeom prst="rect">
+            <a:avLst/>
+          </a:prstGeom>
+          <a:solidFill>
+            <a:srgbClr val="B7914E"/>
+          </a:solidFill>
+          <a:ln>
+            <a:noFill/>
+          </a:ln>
+        </p:spPr>
+        <p:style>
+          <a:lnRef idx="1">
+            <a:schemeClr val="accent1"/>
+          </a:lnRef>
+          <a:fillRef idx="3">
+            <a:schemeClr val="accent1"/>
+          </a:fillRef>
+          <a:effectRef idx="2">
+            <a:schemeClr val="accent1"/>
+          </a:effectRef>
+          <a:fontRef idx="minor">
+            <a:schemeClr val="lt1"/>
+          </a:fontRef>
+        </p:style>
+        <p:txBody>
+          <a:bodyPr rtlCol="0" anchor="ctr"/>
+          <a:lstStyle/>
+          <a:p>
+            <a:pPr algn="ctr"/>
+          </a:p>
+        </p:txBody>
+      </p:sp>
+      <p:sp>
+        <p:nvSpPr>
+          <p:cNvPr id="5" name="TextBox 4"/>
+          <p:cNvSpPr txBox="1"/>
+          <p:nvPr/>
+        </p:nvSpPr>
+        <p:spPr>
+          <a:xfrm>
+            <a:off x="594360" y="6492240"/>
+            <a:ext cx="9144000" cy="228600"/>
+          </a:xfrm>
+          <a:prstGeom prst="rect">
+            <a:avLst/>
+          </a:prstGeom>
+          <a:noFill/>
+        </p:spPr>
+        <p:txBody>
+          <a:bodyPr wrap="square">
+            <a:spAutoFit/>
+          </a:bodyPr>
+          <a:lstStyle/>
+          <a:p>
+            <a:pPr algn="l"/>
+            <a:r>
+              <a:rPr sz="900" b="0">
+                <a:solidFill>
+                  <a:srgbClr val="54686B"/>
+                </a:solidFill>
+                <a:latin typeface="Aptos"/>
+              </a:rPr>
+              <a:t>REGISTROS DO FUNIL • DEFINIÇÕES PROVISÓRIAS • NÃO CAUSAL</a:t>
+            </a:r>
+          </a:p>
+        </p:txBody>
+      </p:sp>
+      <p:sp>
+        <p:nvSpPr>
+          <p:cNvPr id="6" name="TextBox 5"/>
+          <p:cNvSpPr txBox="1"/>
+          <p:nvPr/>
+        </p:nvSpPr>
+        <p:spPr>
+          <a:xfrm>
+            <a:off x="10972800" y="6455664"/>
+            <a:ext cx="731520" cy="274320"/>
+          </a:xfrm>
+          <a:prstGeom prst="rect">
+            <a:avLst/>
+          </a:prstGeom>
+          <a:noFill/>
+        </p:spPr>
+        <p:txBody>
+          <a:bodyPr wrap="square">
+            <a:spAutoFit/>
+          </a:bodyPr>
+          <a:lstStyle/>
+          <a:p>
+            <a:pPr algn="l"/>
+            <a:r>
+              <a:rPr sz="1100" b="1">
+                <a:solidFill>
+                  <a:srgbClr val="285F5B"/>
+                </a:solidFill>
+                <a:latin typeface="Aptos"/>
+              </a:rPr>
+              <a:t>22</a:t>
+            </a:r>
+          </a:p>
+        </p:txBody>
+      </p:sp>
+      <p:sp>
+        <p:nvSpPr>
+          <p:cNvPr id="7" name="TextBox 6"/>
+          <p:cNvSpPr txBox="1"/>
+          <p:nvPr/>
+        </p:nvSpPr>
+        <p:spPr>
+          <a:xfrm>
+            <a:off x="685800" y="1883664"/>
+            <a:ext cx="3383280" cy="731520"/>
+          </a:xfrm>
+          <a:prstGeom prst="rect">
+            <a:avLst/>
+          </a:prstGeom>
+          <a:noFill/>
+        </p:spPr>
+        <p:txBody>
+          <a:bodyPr wrap="square">
+            <a:spAutoFit/>
+          </a:bodyPr>
+          <a:lstStyle/>
+          <a:p>
+            <a:pPr algn="l"/>
+            <a:r>
+              <a:rPr sz="3900" b="1">
+                <a:solidFill>
+                  <a:srgbClr val="285F5B"/>
+                </a:solidFill>
+                <a:latin typeface="Aptos"/>
+              </a:rPr>
+              <a:t>74.255</a:t>
+            </a:r>
+          </a:p>
+        </p:txBody>
+      </p:sp>
+      <p:sp>
+        <p:nvSpPr>
+          <p:cNvPr id="8" name="TextBox 7"/>
+          <p:cNvSpPr txBox="1"/>
+          <p:nvPr/>
+        </p:nvSpPr>
+        <p:spPr>
+          <a:xfrm>
+            <a:off x="685800" y="2706624"/>
+            <a:ext cx="3108960" cy="457200"/>
+          </a:xfrm>
+          <a:prstGeom prst="rect">
+            <a:avLst/>
+          </a:prstGeom>
+          <a:noFill/>
+        </p:spPr>
+        <p:txBody>
+          <a:bodyPr wrap="square">
+            <a:spAutoFit/>
+          </a:bodyPr>
+          <a:lstStyle/>
+          <a:p>
+            <a:pPr algn="l"/>
+            <a:r>
+              <a:rPr sz="1900" b="0">
+                <a:solidFill>
+                  <a:srgbClr val="132B33"/>
+                </a:solidFill>
+                <a:latin typeface="Aptos"/>
+              </a:rPr>
+              <a:t>trocas de código em BL</a:t>
+            </a:r>
+          </a:p>
+        </p:txBody>
+      </p:sp>
+      <p:sp>
+        <p:nvSpPr>
+          <p:cNvPr id="9" name="TextBox 8"/>
+          <p:cNvSpPr txBox="1"/>
+          <p:nvPr/>
+        </p:nvSpPr>
+        <p:spPr>
+          <a:xfrm>
+            <a:off x="685800" y="3547872"/>
+            <a:ext cx="3291840" cy="640080"/>
+          </a:xfrm>
+          <a:prstGeom prst="rect">
+            <a:avLst/>
+          </a:prstGeom>
+          <a:noFill/>
+        </p:spPr>
+        <p:txBody>
+          <a:bodyPr wrap="square">
+            <a:spAutoFit/>
+          </a:bodyPr>
+          <a:lstStyle/>
+          <a:p>
+            <a:pPr algn="l"/>
+            <a:r>
+              <a:rPr sz="3200" b="1">
+                <a:solidFill>
+                  <a:srgbClr val="132B33"/>
+                </a:solidFill>
+                <a:latin typeface="Aptos"/>
+              </a:rPr>
+              <a:t>−22,08</a:t>
+            </a:r>
+          </a:p>
+        </p:txBody>
+      </p:sp>
+      <p:sp>
+        <p:nvSpPr>
+          <p:cNvPr id="10" name="TextBox 9"/>
+          <p:cNvSpPr txBox="1"/>
+          <p:nvPr/>
+        </p:nvSpPr>
+        <p:spPr>
+          <a:xfrm>
+            <a:off x="685800" y="4251960"/>
+            <a:ext cx="3108960" cy="868680"/>
+          </a:xfrm>
+          <a:prstGeom prst="rect">
+            <a:avLst/>
+          </a:prstGeom>
+          <a:noFill/>
+        </p:spPr>
+        <p:txBody>
+          <a:bodyPr wrap="square">
+            <a:spAutoFit/>
+          </a:bodyPr>
+          <a:lstStyle/>
+          <a:p>
+            <a:pPr algn="l"/>
+            <a:r>
+              <a:rPr sz="1600" b="0">
+                <a:solidFill>
+                  <a:srgbClr val="132B33"/>
+                </a:solidFill>
+                <a:latin typeface="Aptos"/>
+              </a:rPr>
+              <a:t>Δ médio de valor em substituições de BL</a:t>
+            </a:r>
+          </a:p>
+        </p:txBody>
+      </p:sp>
+      <p:sp>
+        <p:nvSpPr>
+          <p:cNvPr id="11" name="TextBox 10"/>
+          <p:cNvSpPr txBox="1"/>
+          <p:nvPr/>
+        </p:nvSpPr>
+        <p:spPr>
+          <a:xfrm>
+            <a:off x="4343400" y="1883664"/>
+            <a:ext cx="2834640" cy="731520"/>
+          </a:xfrm>
+          <a:prstGeom prst="rect">
+            <a:avLst/>
+          </a:prstGeom>
+          <a:noFill/>
+        </p:spPr>
+        <p:txBody>
+          <a:bodyPr wrap="square">
+            <a:spAutoFit/>
+          </a:bodyPr>
+          <a:lstStyle/>
+          <a:p>
+            <a:pPr algn="l"/>
+            <a:r>
+              <a:rPr sz="3900" b="1">
+                <a:solidFill>
+                  <a:srgbClr val="285F5B"/>
+                </a:solidFill>
+                <a:latin typeface="Aptos"/>
+              </a:rPr>
+              <a:t>19.381</a:t>
+            </a:r>
+          </a:p>
+        </p:txBody>
+      </p:sp>
+      <p:sp>
+        <p:nvSpPr>
+          <p:cNvPr id="12" name="TextBox 11"/>
+          <p:cNvSpPr txBox="1"/>
+          <p:nvPr/>
+        </p:nvSpPr>
+        <p:spPr>
+          <a:xfrm>
+            <a:off x="4343400" y="2706624"/>
+            <a:ext cx="3017520" cy="457200"/>
+          </a:xfrm>
+          <a:prstGeom prst="rect">
+            <a:avLst/>
+          </a:prstGeom>
+          <a:noFill/>
+        </p:spPr>
+        <p:txBody>
+          <a:bodyPr wrap="square">
+            <a:spAutoFit/>
+          </a:bodyPr>
+          <a:lstStyle/>
+          <a:p>
+            <a:pPr algn="l"/>
+            <a:r>
+              <a:rPr sz="1900" b="0">
+                <a:solidFill>
+                  <a:srgbClr val="132B33"/>
+                </a:solidFill>
+                <a:latin typeface="Aptos"/>
+              </a:rPr>
+              <a:t>remoções de TV</a:t>
+            </a:r>
+          </a:p>
+        </p:txBody>
+      </p:sp>
+      <p:sp>
+        <p:nvSpPr>
+          <p:cNvPr id="13" name="TextBox 12"/>
+          <p:cNvSpPr txBox="1"/>
+          <p:nvPr/>
+        </p:nvSpPr>
+        <p:spPr>
+          <a:xfrm>
+            <a:off x="4343400" y="3547872"/>
+            <a:ext cx="3200400" cy="640080"/>
+          </a:xfrm>
+          <a:prstGeom prst="rect">
+            <a:avLst/>
+          </a:prstGeom>
+          <a:noFill/>
+        </p:spPr>
+        <p:txBody>
+          <a:bodyPr wrap="square">
+            <a:spAutoFit/>
+          </a:bodyPr>
+          <a:lstStyle/>
+          <a:p>
+            <a:pPr algn="l"/>
+            <a:r>
+              <a:rPr sz="3200" b="1">
+                <a:solidFill>
+                  <a:srgbClr val="132B33"/>
+                </a:solidFill>
+                <a:latin typeface="Aptos"/>
+              </a:rPr>
+              <a:t>−118,33</a:t>
+            </a:r>
+          </a:p>
+        </p:txBody>
+      </p:sp>
+      <p:sp>
+        <p:nvSpPr>
+          <p:cNvPr id="14" name="TextBox 13"/>
+          <p:cNvSpPr txBox="1"/>
+          <p:nvPr/>
+        </p:nvSpPr>
+        <p:spPr>
+          <a:xfrm>
+            <a:off x="4343400" y="4251960"/>
+            <a:ext cx="2926080" cy="868680"/>
+          </a:xfrm>
+          <a:prstGeom prst="rect">
+            <a:avLst/>
+          </a:prstGeom>
+          <a:noFill/>
+        </p:spPr>
+        <p:txBody>
+          <a:bodyPr wrap="square">
+            <a:spAutoFit/>
+          </a:bodyPr>
+          <a:lstStyle/>
+          <a:p>
+            <a:pPr algn="l"/>
+            <a:r>
+              <a:rPr sz="1600" b="0">
+                <a:solidFill>
+                  <a:srgbClr val="132B33"/>
+                </a:solidFill>
+                <a:latin typeface="Aptos"/>
+              </a:rPr>
+              <a:t>Δ médio por remoção de TV</a:t>
+            </a:r>
+          </a:p>
+        </p:txBody>
+      </p:sp>
+      <p:sp>
+        <p:nvSpPr>
+          <p:cNvPr id="15" name="TextBox 14"/>
+          <p:cNvSpPr txBox="1"/>
+          <p:nvPr/>
+        </p:nvSpPr>
+        <p:spPr>
+          <a:xfrm>
+            <a:off x="8138160" y="1883664"/>
+            <a:ext cx="2834640" cy="731520"/>
+          </a:xfrm>
+          <a:prstGeom prst="rect">
+            <a:avLst/>
+          </a:prstGeom>
+          <a:noFill/>
+        </p:spPr>
+        <p:txBody>
+          <a:bodyPr wrap="square">
+            <a:spAutoFit/>
+          </a:bodyPr>
+          <a:lstStyle/>
+          <a:p>
+            <a:pPr algn="l"/>
+            <a:r>
+              <a:rPr sz="3900" b="1">
+                <a:solidFill>
+                  <a:srgbClr val="285F5B"/>
+                </a:solidFill>
+                <a:latin typeface="Aptos"/>
+              </a:rPr>
+              <a:t>13.161</a:t>
+            </a:r>
+          </a:p>
+        </p:txBody>
+      </p:sp>
+      <p:sp>
+        <p:nvSpPr>
+          <p:cNvPr id="16" name="TextBox 15"/>
+          <p:cNvSpPr txBox="1"/>
+          <p:nvPr/>
+        </p:nvSpPr>
+        <p:spPr>
+          <a:xfrm>
+            <a:off x="8138160" y="2697480"/>
+            <a:ext cx="3200400" cy="1097280"/>
+          </a:xfrm>
+          <a:prstGeom prst="rect">
+            <a:avLst/>
+          </a:prstGeom>
+          <a:noFill/>
+        </p:spPr>
+        <p:txBody>
+          <a:bodyPr wrap="square">
+            <a:spAutoFit/>
+          </a:bodyPr>
+          <a:lstStyle/>
+          <a:p>
+            <a:pPr algn="l"/>
+            <a:r>
+              <a:rPr sz="1800" b="0">
+                <a:solidFill>
+                  <a:srgbClr val="132B33"/>
+                </a:solidFill>
+                <a:latin typeface="Aptos"/>
+              </a:rPr>
+              <a:t>retidos com movimento e cancelamento</a:t>
+            </a:r>
+          </a:p>
+        </p:txBody>
+      </p:sp>
+      <p:sp>
+        <p:nvSpPr>
+          <p:cNvPr id="17" name="TextBox 16"/>
+          <p:cNvSpPr txBox="1"/>
+          <p:nvPr/>
+        </p:nvSpPr>
+        <p:spPr>
+          <a:xfrm>
+            <a:off x="8138160" y="3794760"/>
+            <a:ext cx="3200400" cy="640080"/>
+          </a:xfrm>
+          <a:prstGeom prst="rect">
+            <a:avLst/>
+          </a:prstGeom>
+          <a:noFill/>
+        </p:spPr>
+        <p:txBody>
+          <a:bodyPr wrap="square">
+            <a:spAutoFit/>
+          </a:bodyPr>
+          <a:lstStyle/>
+          <a:p>
+            <a:pPr algn="l"/>
+            <a:r>
+              <a:rPr sz="3200" b="1">
+                <a:solidFill>
+                  <a:srgbClr val="132B33"/>
+                </a:solidFill>
+                <a:latin typeface="Aptos"/>
+              </a:rPr>
+              <a:t>−88,96</a:t>
+            </a:r>
+          </a:p>
+        </p:txBody>
+      </p:sp>
+      <p:sp>
+        <p:nvSpPr>
+          <p:cNvPr id="18" name="TextBox 17"/>
+          <p:cNvSpPr txBox="1"/>
+          <p:nvPr/>
+        </p:nvSpPr>
+        <p:spPr>
+          <a:xfrm>
+            <a:off x="8138160" y="4517136"/>
+            <a:ext cx="2971800" cy="685800"/>
+          </a:xfrm>
+          <a:prstGeom prst="rect">
+            <a:avLst/>
+          </a:prstGeom>
+          <a:noFill/>
+        </p:spPr>
+        <p:txBody>
+          <a:bodyPr wrap="square">
+            <a:spAutoFit/>
+          </a:bodyPr>
+          <a:lstStyle/>
+          <a:p>
+            <a:pPr algn="l"/>
+            <a:r>
+              <a:rPr sz="1600" b="0">
+                <a:solidFill>
+                  <a:srgbClr val="132B33"/>
+                </a:solidFill>
+                <a:latin typeface="Aptos"/>
+              </a:rPr>
+              <a:t>mediana ΔV do subgrupo</a:t>
+            </a:r>
+          </a:p>
+        </p:txBody>
+      </p:sp>
+      <p:sp>
+        <p:nvSpPr>
+          <p:cNvPr id="19" name="TextBox 18"/>
+          <p:cNvSpPr txBox="1"/>
+          <p:nvPr/>
+        </p:nvSpPr>
+        <p:spPr>
+          <a:xfrm>
+            <a:off x="685800" y="5852160"/>
+            <a:ext cx="10424160" cy="420624"/>
+          </a:xfrm>
+          <a:prstGeom prst="rect">
+            <a:avLst/>
+          </a:prstGeom>
+          <a:noFill/>
+        </p:spPr>
+        <p:txBody>
+          <a:bodyPr wrap="square">
+            <a:spAutoFit/>
+          </a:bodyPr>
+          <a:lstStyle/>
+          <a:p>
+            <a:pPr algn="l"/>
+            <a:r>
+              <a:rPr sz="1500" b="0">
+                <a:solidFill>
+                  <a:srgbClr val="54686B"/>
+                </a:solidFill>
+                <a:latin typeface="Aptos"/>
+              </a:rPr>
+              <a:t>ΔV: valor registrado M30−M0, não perda contábil ou lucro incremental.</a:t>
+            </a:r>
+          </a:p>
+        </p:txBody>
+      </p:sp>
+    </p:spTree>
+  </p:cSld>
+  <p:clrMapOvr>
+    <a:masterClrMapping/>
+  </p:clrMapOvr>
+</p:sld>
+</file>
+
+<file path=ppt/slides/slide23.xml><?xml version="1.0" encoding="utf-8"?>
+<p:sld xmlns:a="http://schemas.openxmlformats.org/drawingml/2006/main" xmlns:p="http://schemas.openxmlformats.org/presentationml/2006/main" xmlns:r="http://schemas.openxmlformats.org/officeDocument/2006/relationships">
+  <p:cSld>
+    <p:spTree>
+      <p:nvGrpSpPr>
+        <p:cNvPr id="1" name=""/>
+        <p:cNvGrpSpPr/>
+        <p:nvPr/>
+      </p:nvGrpSpPr>
+      <p:grpSpPr/>
+      <p:sp>
+        <p:nvSpPr>
+          <p:cNvPr id="2" name="TextBox 1"/>
+          <p:cNvSpPr txBox="1"/>
+          <p:nvPr/>
+        </p:nvSpPr>
+        <p:spPr>
+          <a:xfrm>
+            <a:off x="594360" y="274320"/>
+            <a:ext cx="8229600" cy="320040"/>
+          </a:xfrm>
+          <a:prstGeom prst="rect">
+            <a:avLst/>
+          </a:prstGeom>
+          <a:noFill/>
+        </p:spPr>
+        <p:txBody>
+          <a:bodyPr wrap="square">
+            <a:spAutoFit/>
+          </a:bodyPr>
+          <a:lstStyle/>
+          <a:p>
+            <a:pPr algn="l"/>
+            <a:r>
+              <a:rPr sz="1300" b="1">
+                <a:solidFill>
+                  <a:srgbClr val="285F5B"/>
+                </a:solidFill>
+                <a:latin typeface="Aptos"/>
+              </a:rPr>
+              <a:t>ESTUDO OBSERVACIONAL | JUN–DEZ 2025</a:t>
+            </a:r>
+          </a:p>
+        </p:txBody>
+      </p:sp>
+      <p:sp>
+        <p:nvSpPr>
+          <p:cNvPr id="3" name="TextBox 2"/>
+          <p:cNvSpPr txBox="1"/>
+          <p:nvPr/>
+        </p:nvSpPr>
+        <p:spPr>
+          <a:xfrm>
+            <a:off x="594360" y="685800"/>
+            <a:ext cx="11064240" cy="685800"/>
+          </a:xfrm>
+          <a:prstGeom prst="rect">
+            <a:avLst/>
+          </a:prstGeom>
+          <a:noFill/>
+        </p:spPr>
+        <p:txBody>
+          <a:bodyPr wrap="square">
+            <a:spAutoFit/>
+          </a:bodyPr>
+          <a:lstStyle/>
+          <a:p>
+            <a:pPr algn="l"/>
+            <a:r>
+              <a:rPr sz="3000" b="1">
+                <a:solidFill>
+                  <a:srgbClr val="132B33"/>
+                </a:solidFill>
+                <a:latin typeface="Aptos"/>
+              </a:rPr>
+              <a:t>SOLAR versus LEGADO: associação, não efeito do canal</a:t>
+            </a:r>
+          </a:p>
+        </p:txBody>
+      </p:sp>
+      <p:sp>
+        <p:nvSpPr>
+          <p:cNvPr id="4" name="Rectangle 3"/>
+          <p:cNvSpPr/>
+          <p:nvPr/>
+        </p:nvSpPr>
+        <p:spPr>
+          <a:xfrm>
+            <a:off x="594360" y="1463040"/>
+            <a:ext cx="11018520" cy="25603"/>
+          </a:xfrm>
+          <a:prstGeom prst="rect">
+            <a:avLst/>
+          </a:prstGeom>
+          <a:solidFill>
+            <a:srgbClr val="B7914E"/>
+          </a:solidFill>
+          <a:ln>
+            <a:noFill/>
+          </a:ln>
+        </p:spPr>
+        <p:style>
+          <a:lnRef idx="1">
+            <a:schemeClr val="accent1"/>
+          </a:lnRef>
+          <a:fillRef idx="3">
+            <a:schemeClr val="accent1"/>
+          </a:fillRef>
+          <a:effectRef idx="2">
+            <a:schemeClr val="accent1"/>
+          </a:effectRef>
+          <a:fontRef idx="minor">
+            <a:schemeClr val="lt1"/>
+          </a:fontRef>
+        </p:style>
+        <p:txBody>
+          <a:bodyPr rtlCol="0" anchor="ctr"/>
+          <a:lstStyle/>
+          <a:p>
+            <a:pPr algn="ctr"/>
+          </a:p>
+        </p:txBody>
+      </p:sp>
+      <p:sp>
+        <p:nvSpPr>
+          <p:cNvPr id="5" name="TextBox 4"/>
+          <p:cNvSpPr txBox="1"/>
+          <p:nvPr/>
+        </p:nvSpPr>
+        <p:spPr>
+          <a:xfrm>
+            <a:off x="594360" y="6492240"/>
+            <a:ext cx="9144000" cy="228600"/>
+          </a:xfrm>
+          <a:prstGeom prst="rect">
+            <a:avLst/>
+          </a:prstGeom>
+          <a:noFill/>
+        </p:spPr>
+        <p:txBody>
+          <a:bodyPr wrap="square">
+            <a:spAutoFit/>
+          </a:bodyPr>
+          <a:lstStyle/>
+          <a:p>
+            <a:pPr algn="l"/>
+            <a:r>
+              <a:rPr sz="900" b="0">
+                <a:solidFill>
+                  <a:srgbClr val="54686B"/>
+                </a:solidFill>
+                <a:latin typeface="Aptos"/>
+              </a:rPr>
+              <a:t>REGISTROS DO FUNIL • DEFINIÇÕES PROVISÓRIAS • NÃO CAUSAL</a:t>
+            </a:r>
+          </a:p>
+        </p:txBody>
+      </p:sp>
+      <p:sp>
+        <p:nvSpPr>
+          <p:cNvPr id="6" name="TextBox 5"/>
+          <p:cNvSpPr txBox="1"/>
+          <p:nvPr/>
+        </p:nvSpPr>
+        <p:spPr>
+          <a:xfrm>
+            <a:off x="10972800" y="6455664"/>
+            <a:ext cx="731520" cy="274320"/>
+          </a:xfrm>
+          <a:prstGeom prst="rect">
+            <a:avLst/>
+          </a:prstGeom>
+          <a:noFill/>
+        </p:spPr>
+        <p:txBody>
+          <a:bodyPr wrap="square">
+            <a:spAutoFit/>
+          </a:bodyPr>
+          <a:lstStyle/>
+          <a:p>
+            <a:pPr algn="l"/>
+            <a:r>
+              <a:rPr sz="1100" b="1">
+                <a:solidFill>
+                  <a:srgbClr val="285F5B"/>
+                </a:solidFill>
+                <a:latin typeface="Aptos"/>
+              </a:rPr>
+              <a:t>23</a:t>
+            </a:r>
+          </a:p>
+        </p:txBody>
+      </p:sp>
+      <p:pic>
+        <p:nvPicPr>
+          <p:cNvPr id="7" name="Picture 6" descr="channel_standardized_gap.png"/>
+          <p:cNvPicPr>
+            <a:picLocks noChangeAspect="1"/>
+          </p:cNvPicPr>
+          <p:nvPr/>
+        </p:nvPicPr>
+        <p:blipFill>
+          <a:blip r:embed="rId2"/>
+          <a:stretch>
+            <a:fillRect/>
+          </a:stretch>
+        </p:blipFill>
+        <p:spPr>
+          <a:xfrm>
+            <a:off x="685800" y="1783080"/>
+            <a:ext cx="7406640" cy="3234233"/>
+          </a:xfrm>
+          <a:prstGeom prst="rect">
+            <a:avLst/>
+          </a:prstGeom>
+        </p:spPr>
+      </p:pic>
+      <p:sp>
+        <p:nvSpPr>
+          <p:cNvPr id="8" name="TextBox 7"/>
+          <p:cNvSpPr txBox="1"/>
+          <p:nvPr/>
+        </p:nvSpPr>
+        <p:spPr>
+          <a:xfrm>
+            <a:off x="8321040" y="2011680"/>
+            <a:ext cx="3108960" cy="612648"/>
+          </a:xfrm>
+          <a:prstGeom prst="rect">
+            <a:avLst/>
+          </a:prstGeom>
+          <a:noFill/>
+        </p:spPr>
+        <p:txBody>
+          <a:bodyPr wrap="square">
+            <a:spAutoFit/>
+          </a:bodyPr>
+          <a:lstStyle/>
+          <a:p>
+            <a:pPr algn="l"/>
+            <a:r>
+              <a:rPr sz="2900" b="1">
+                <a:solidFill>
+                  <a:srgbClr val="285F5B"/>
+                </a:solidFill>
+                <a:latin typeface="Aptos"/>
+              </a:rPr>
+              <a:t>+2,93 p.p.</a:t>
+            </a:r>
+          </a:p>
+        </p:txBody>
+      </p:sp>
+      <p:sp>
+        <p:nvSpPr>
+          <p:cNvPr id="9" name="TextBox 8"/>
+          <p:cNvSpPr txBox="1"/>
+          <p:nvPr/>
+        </p:nvSpPr>
+        <p:spPr>
+          <a:xfrm>
+            <a:off x="8321040" y="2651760"/>
+            <a:ext cx="3200400" cy="1097280"/>
+          </a:xfrm>
+          <a:prstGeom prst="rect">
+            <a:avLst/>
+          </a:prstGeom>
+          <a:noFill/>
+        </p:spPr>
+        <p:txBody>
+          <a:bodyPr wrap="square">
+            <a:spAutoFit/>
+          </a:bodyPr>
+          <a:lstStyle/>
+          <a:p>
+            <a:pPr algn="l"/>
+            <a:r>
+              <a:rPr sz="1700" b="0">
+                <a:solidFill>
+                  <a:srgbClr val="132B33"/>
+                </a:solidFill>
+                <a:latin typeface="Aptos"/>
+              </a:rPr>
+              <a:t>diferença após padronizar mês e nº de famílias M0</a:t>
+            </a:r>
+          </a:p>
+        </p:txBody>
+      </p:sp>
+      <p:sp>
+        <p:nvSpPr>
+          <p:cNvPr id="10" name="TextBox 9"/>
+          <p:cNvSpPr txBox="1"/>
+          <p:nvPr/>
+        </p:nvSpPr>
+        <p:spPr>
+          <a:xfrm>
+            <a:off x="8321040" y="4005072"/>
+            <a:ext cx="3200400" cy="320040"/>
+          </a:xfrm>
+          <a:prstGeom prst="rect">
+            <a:avLst/>
+          </a:prstGeom>
+          <a:noFill/>
+        </p:spPr>
+        <p:txBody>
+          <a:bodyPr wrap="square">
+            <a:spAutoFit/>
+          </a:bodyPr>
+          <a:lstStyle/>
+          <a:p>
+            <a:pPr algn="l"/>
+            <a:r>
+              <a:rPr sz="1400" b="0">
+                <a:solidFill>
+                  <a:srgbClr val="54686B"/>
+                </a:solidFill>
+                <a:latin typeface="Aptos"/>
+              </a:rPr>
+              <a:t>IC 95% agrupado por cliente:</a:t>
+            </a:r>
+          </a:p>
+        </p:txBody>
+      </p:sp>
+      <p:sp>
+        <p:nvSpPr>
+          <p:cNvPr id="11" name="TextBox 10"/>
+          <p:cNvSpPr txBox="1"/>
+          <p:nvPr/>
+        </p:nvSpPr>
+        <p:spPr>
+          <a:xfrm>
+            <a:off x="8321040" y="4389120"/>
+            <a:ext cx="3246120" cy="530352"/>
+          </a:xfrm>
+          <a:prstGeom prst="rect">
+            <a:avLst/>
+          </a:prstGeom>
+          <a:noFill/>
+        </p:spPr>
+        <p:txBody>
+          <a:bodyPr wrap="square">
+            <a:spAutoFit/>
+          </a:bodyPr>
+          <a:lstStyle/>
+          <a:p>
+            <a:pPr algn="l"/>
+            <a:r>
+              <a:rPr sz="1800" b="1">
+                <a:solidFill>
+                  <a:srgbClr val="132B33"/>
+                </a:solidFill>
+                <a:latin typeface="Aptos"/>
+              </a:rPr>
+              <a:t>[+2,53; +3,41] p.p.</a:t>
+            </a:r>
+          </a:p>
+        </p:txBody>
+      </p:sp>
+      <p:sp>
+        <p:nvSpPr>
+          <p:cNvPr id="12" name="TextBox 11"/>
+          <p:cNvSpPr txBox="1"/>
+          <p:nvPr/>
+        </p:nvSpPr>
+        <p:spPr>
+          <a:xfrm>
+            <a:off x="8321040" y="5120640"/>
+            <a:ext cx="3017520" cy="731520"/>
+          </a:xfrm>
+          <a:prstGeom prst="rect">
+            <a:avLst/>
+          </a:prstGeom>
+          <a:noFill/>
+        </p:spPr>
+        <p:txBody>
+          <a:bodyPr wrap="square">
+            <a:spAutoFit/>
+          </a:bodyPr>
+          <a:lstStyle/>
+          <a:p>
+            <a:pPr algn="l"/>
+            <a:r>
+              <a:rPr sz="1400" b="0">
+                <a:solidFill>
+                  <a:srgbClr val="54686B"/>
+                </a:solidFill>
+                <a:latin typeface="Aptos"/>
+              </a:rPr>
+              <a:t>200 réplicas; sem controle de seleção/confundimento.</a:t>
+            </a:r>
+          </a:p>
+        </p:txBody>
+      </p:sp>
+    </p:spTree>
+  </p:cSld>
+  <p:clrMapOvr>
+    <a:masterClrMapping/>
+  </p:clrMapOvr>
+</p:sld>
+</file>
+
+<file path=ppt/slides/slide24.xml><?xml version="1.0" encoding="utf-8"?>
+<p:sld xmlns:a="http://schemas.openxmlformats.org/drawingml/2006/main" xmlns:p="http://schemas.openxmlformats.org/presentationml/2006/main" xmlns:r="http://schemas.openxmlformats.org/officeDocument/2006/relationships">
+  <p:cSld>
+    <p:spTree>
+      <p:nvGrpSpPr>
+        <p:cNvPr id="1" name=""/>
+        <p:cNvGrpSpPr/>
+        <p:nvPr/>
+      </p:nvGrpSpPr>
+      <p:grpSpPr/>
+      <p:sp>
+        <p:nvSpPr>
+          <p:cNvPr id="2" name="TextBox 1"/>
+          <p:cNvSpPr txBox="1"/>
+          <p:nvPr/>
+        </p:nvSpPr>
+        <p:spPr>
+          <a:xfrm>
+            <a:off x="594360" y="274320"/>
+            <a:ext cx="8229600" cy="320040"/>
+          </a:xfrm>
+          <a:prstGeom prst="rect">
+            <a:avLst/>
+          </a:prstGeom>
+          <a:noFill/>
+        </p:spPr>
+        <p:txBody>
+          <a:bodyPr wrap="square">
+            <a:spAutoFit/>
+          </a:bodyPr>
+          <a:lstStyle/>
+          <a:p>
+            <a:pPr algn="l"/>
+            <a:r>
+              <a:rPr sz="1300" b="1">
+                <a:solidFill>
+                  <a:srgbClr val="285F5B"/>
+                </a:solidFill>
+                <a:latin typeface="Aptos"/>
+              </a:rPr>
+              <a:t>ESTUDO OBSERVACIONAL | JUN–DEZ 2025</a:t>
+            </a:r>
+          </a:p>
+        </p:txBody>
+      </p:sp>
+      <p:sp>
+        <p:nvSpPr>
+          <p:cNvPr id="3" name="TextBox 2"/>
+          <p:cNvSpPr txBox="1"/>
+          <p:nvPr/>
+        </p:nvSpPr>
+        <p:spPr>
+          <a:xfrm>
+            <a:off x="594360" y="685800"/>
+            <a:ext cx="11064240" cy="685800"/>
+          </a:xfrm>
+          <a:prstGeom prst="rect">
+            <a:avLst/>
+          </a:prstGeom>
+          <a:noFill/>
+        </p:spPr>
+        <p:txBody>
+          <a:bodyPr wrap="square">
+            <a:spAutoFit/>
+          </a:bodyPr>
+          <a:lstStyle/>
+          <a:p>
+            <a:pPr algn="l"/>
+            <a:r>
+              <a:rPr sz="3000" b="1">
+                <a:solidFill>
+                  <a:srgbClr val="132B33"/>
+                </a:solidFill>
+                <a:latin typeface="Aptos"/>
+              </a:rPr>
+              <a:t>Abertos por origem: limites em vez de falsa sobrevida</a:t>
+            </a:r>
+          </a:p>
+        </p:txBody>
+      </p:sp>
+      <p:sp>
+        <p:nvSpPr>
+          <p:cNvPr id="4" name="Rectangle 3"/>
+          <p:cNvSpPr/>
+          <p:nvPr/>
+        </p:nvSpPr>
+        <p:spPr>
+          <a:xfrm>
+            <a:off x="594360" y="1463040"/>
+            <a:ext cx="11018520" cy="25603"/>
+          </a:xfrm>
+          <a:prstGeom prst="rect">
+            <a:avLst/>
+          </a:prstGeom>
+          <a:solidFill>
+            <a:srgbClr val="B7914E"/>
+          </a:solidFill>
+          <a:ln>
+            <a:noFill/>
+          </a:ln>
+        </p:spPr>
+        <p:style>
+          <a:lnRef idx="1">
+            <a:schemeClr val="accent1"/>
+          </a:lnRef>
+          <a:fillRef idx="3">
+            <a:schemeClr val="accent1"/>
+          </a:fillRef>
+          <a:effectRef idx="2">
+            <a:schemeClr val="accent1"/>
+          </a:effectRef>
+          <a:fontRef idx="minor">
+            <a:schemeClr val="lt1"/>
+          </a:fontRef>
+        </p:style>
+        <p:txBody>
+          <a:bodyPr rtlCol="0" anchor="ctr"/>
+          <a:lstStyle/>
+          <a:p>
+            <a:pPr algn="ctr"/>
+          </a:p>
+        </p:txBody>
+      </p:sp>
+      <p:sp>
+        <p:nvSpPr>
+          <p:cNvPr id="5" name="TextBox 4"/>
+          <p:cNvSpPr txBox="1"/>
+          <p:nvPr/>
+        </p:nvSpPr>
+        <p:spPr>
+          <a:xfrm>
+            <a:off x="594360" y="6492240"/>
+            <a:ext cx="9144000" cy="228600"/>
+          </a:xfrm>
+          <a:prstGeom prst="rect">
+            <a:avLst/>
+          </a:prstGeom>
+          <a:noFill/>
+        </p:spPr>
+        <p:txBody>
+          <a:bodyPr wrap="square">
+            <a:spAutoFit/>
+          </a:bodyPr>
+          <a:lstStyle/>
+          <a:p>
+            <a:pPr algn="l"/>
+            <a:r>
+              <a:rPr sz="900" b="0">
+                <a:solidFill>
+                  <a:srgbClr val="54686B"/>
+                </a:solidFill>
+                <a:latin typeface="Aptos"/>
+              </a:rPr>
+              <a:t>REGISTROS DO FUNIL • DEFINIÇÕES PROVISÓRIAS • NÃO CAUSAL</a:t>
+            </a:r>
+          </a:p>
+        </p:txBody>
+      </p:sp>
+      <p:sp>
+        <p:nvSpPr>
+          <p:cNvPr id="6" name="TextBox 5"/>
+          <p:cNvSpPr txBox="1"/>
+          <p:nvPr/>
+        </p:nvSpPr>
+        <p:spPr>
+          <a:xfrm>
+            <a:off x="10972800" y="6455664"/>
+            <a:ext cx="731520" cy="274320"/>
+          </a:xfrm>
+          <a:prstGeom prst="rect">
+            <a:avLst/>
+          </a:prstGeom>
+          <a:noFill/>
+        </p:spPr>
+        <p:txBody>
+          <a:bodyPr wrap="square">
+            <a:spAutoFit/>
+          </a:bodyPr>
+          <a:lstStyle/>
+          <a:p>
+            <a:pPr algn="l"/>
+            <a:r>
+              <a:rPr sz="1100" b="1">
+                <a:solidFill>
+                  <a:srgbClr val="285F5B"/>
+                </a:solidFill>
+                <a:latin typeface="Aptos"/>
+              </a:rPr>
+              <a:t>24</a:t>
+            </a:r>
+          </a:p>
+        </p:txBody>
+      </p:sp>
+      <p:pic>
+        <p:nvPicPr>
+          <p:cNvPr id="7" name="Picture 6" descr="outcome_bounds_by_origin.png"/>
+          <p:cNvPicPr>
+            <a:picLocks noChangeAspect="1"/>
+          </p:cNvPicPr>
+          <p:nvPr/>
+        </p:nvPicPr>
+        <p:blipFill>
+          <a:blip r:embed="rId2"/>
+          <a:stretch>
+            <a:fillRect/>
+          </a:stretch>
+        </p:blipFill>
+        <p:spPr>
+          <a:xfrm>
+            <a:off x="530352" y="1655064"/>
+            <a:ext cx="8001000" cy="3407092"/>
+          </a:xfrm>
+          <a:prstGeom prst="rect">
+            <a:avLst/>
+          </a:prstGeom>
+        </p:spPr>
+      </p:pic>
+      <p:sp>
+        <p:nvSpPr>
+          <p:cNvPr id="8" name="TextBox 7"/>
+          <p:cNvSpPr txBox="1"/>
+          <p:nvPr/>
+        </p:nvSpPr>
+        <p:spPr>
+          <a:xfrm>
+            <a:off x="8686800" y="1828800"/>
+            <a:ext cx="3017520" cy="457200"/>
+          </a:xfrm>
+          <a:prstGeom prst="rect">
+            <a:avLst/>
+          </a:prstGeom>
+          <a:noFill/>
+        </p:spPr>
+        <p:txBody>
+          <a:bodyPr wrap="square">
+            <a:spAutoFit/>
+          </a:bodyPr>
+          <a:lstStyle/>
+          <a:p>
+            <a:pPr algn="l"/>
+            <a:r>
+              <a:rPr sz="1800" b="1">
+                <a:solidFill>
+                  <a:srgbClr val="285F5B"/>
+                </a:solidFill>
+                <a:latin typeface="Aptos"/>
+              </a:rPr>
+              <a:t>LEGADO em dez/25</a:t>
+            </a:r>
+          </a:p>
+        </p:txBody>
+      </p:sp>
+      <p:sp>
+        <p:nvSpPr>
+          <p:cNvPr id="9" name="TextBox 8"/>
+          <p:cNvSpPr txBox="1"/>
+          <p:nvPr/>
+        </p:nvSpPr>
+        <p:spPr>
+          <a:xfrm>
+            <a:off x="8686800" y="2450592"/>
+            <a:ext cx="2926080" cy="457200"/>
+          </a:xfrm>
+          <a:prstGeom prst="rect">
+            <a:avLst/>
+          </a:prstGeom>
+          <a:noFill/>
+        </p:spPr>
+        <p:txBody>
+          <a:bodyPr wrap="square">
+            <a:spAutoFit/>
+          </a:bodyPr>
+          <a:lstStyle/>
+          <a:p>
+            <a:pPr algn="l"/>
+            <a:r>
+              <a:rPr sz="2400" b="1">
+                <a:solidFill>
+                  <a:srgbClr val="132B33"/>
+                </a:solidFill>
+                <a:latin typeface="Aptos"/>
+              </a:rPr>
+              <a:t>1.464 abertos</a:t>
+            </a:r>
+          </a:p>
+        </p:txBody>
+      </p:sp>
+      <p:sp>
+        <p:nvSpPr>
+          <p:cNvPr id="10" name="TextBox 9"/>
+          <p:cNvSpPr txBox="1"/>
+          <p:nvPr/>
+        </p:nvSpPr>
+        <p:spPr>
+          <a:xfrm>
+            <a:off x="8686800" y="3291840"/>
+            <a:ext cx="2743200" cy="1188720"/>
+          </a:xfrm>
+          <a:prstGeom prst="rect">
+            <a:avLst/>
+          </a:prstGeom>
+          <a:noFill/>
+        </p:spPr>
+        <p:txBody>
+          <a:bodyPr wrap="square">
+            <a:spAutoFit/>
+          </a:bodyPr>
+          <a:lstStyle/>
+          <a:p>
+            <a:pPr algn="l"/>
+            <a:r>
+              <a:rPr sz="1700" b="0">
+                <a:solidFill>
+                  <a:srgbClr val="132B33"/>
+                </a:solidFill>
+                <a:latin typeface="Aptos"/>
+              </a:rPr>
+              <a:t>Status retido possível: 72,8%–84,9% entre todos os leads da coorte.</a:t>
+            </a:r>
+          </a:p>
+        </p:txBody>
+      </p:sp>
+      <p:sp>
+        <p:nvSpPr>
+          <p:cNvPr id="11" name="TextBox 10"/>
+          <p:cNvSpPr txBox="1"/>
+          <p:nvPr/>
+        </p:nvSpPr>
+        <p:spPr>
+          <a:xfrm>
+            <a:off x="8686800" y="4800600"/>
+            <a:ext cx="2743200" cy="1280160"/>
+          </a:xfrm>
+          <a:prstGeom prst="rect">
+            <a:avLst/>
+          </a:prstGeom>
+          <a:noFill/>
+        </p:spPr>
+        <p:txBody>
+          <a:bodyPr wrap="square">
+            <a:spAutoFit/>
+          </a:bodyPr>
+          <a:lstStyle/>
+          <a:p>
+            <a:pPr algn="l"/>
+            <a:r>
+              <a:rPr sz="1500" b="0">
+                <a:solidFill>
+                  <a:srgbClr val="54686B"/>
+                </a:solidFill>
+                <a:latin typeface="Aptos"/>
+              </a:rPr>
+              <a:t>M0/M30 sem tempo de evento: não cabem Kaplan–Meier nem Cox.</a:t>
+            </a:r>
+          </a:p>
+        </p:txBody>
+      </p:sp>
+    </p:spTree>
+  </p:cSld>
+  <p:clrMapOvr>
+    <a:masterClrMapping/>
+  </p:clrMapOvr>
+</p:sld>
+</file>
+
+<file path=ppt/slides/slide25.xml><?xml version="1.0" encoding="utf-8"?>
+<p:sld xmlns:a="http://schemas.openxmlformats.org/drawingml/2006/main" xmlns:p="http://schemas.openxmlformats.org/presentationml/2006/main" xmlns:r="http://schemas.openxmlformats.org/officeDocument/2006/relationships">
+  <p:cSld>
+    <p:spTree>
+      <p:nvGrpSpPr>
+        <p:cNvPr id="1" name=""/>
+        <p:cNvGrpSpPr/>
+        <p:nvPr/>
+      </p:nvGrpSpPr>
+      <p:grpSpPr/>
+      <p:sp>
+        <p:nvSpPr>
+          <p:cNvPr id="2" name="TextBox 1"/>
+          <p:cNvSpPr txBox="1"/>
+          <p:nvPr/>
+        </p:nvSpPr>
+        <p:spPr>
+          <a:xfrm>
+            <a:off x="594360" y="274320"/>
+            <a:ext cx="8229600" cy="320040"/>
+          </a:xfrm>
+          <a:prstGeom prst="rect">
+            <a:avLst/>
+          </a:prstGeom>
+          <a:noFill/>
+        </p:spPr>
+        <p:txBody>
+          <a:bodyPr wrap="square">
+            <a:spAutoFit/>
+          </a:bodyPr>
+          <a:lstStyle/>
+          <a:p>
+            <a:pPr algn="l"/>
+            <a:r>
+              <a:rPr sz="1300" b="1">
+                <a:solidFill>
+                  <a:srgbClr val="285F5B"/>
+                </a:solidFill>
+                <a:latin typeface="Aptos"/>
+              </a:rPr>
+              <a:t>ESTUDO OBSERVACIONAL | JUN–DEZ 2025</a:t>
+            </a:r>
+          </a:p>
+        </p:txBody>
+      </p:sp>
+      <p:sp>
+        <p:nvSpPr>
+          <p:cNvPr id="3" name="TextBox 2"/>
+          <p:cNvSpPr txBox="1"/>
+          <p:nvPr/>
+        </p:nvSpPr>
+        <p:spPr>
+          <a:xfrm>
+            <a:off x="594360" y="685800"/>
+            <a:ext cx="11064240" cy="685800"/>
+          </a:xfrm>
+          <a:prstGeom prst="rect">
+            <a:avLst/>
+          </a:prstGeom>
+          <a:noFill/>
+        </p:spPr>
+        <p:txBody>
+          <a:bodyPr wrap="square">
+            <a:spAutoFit/>
+          </a:bodyPr>
+          <a:lstStyle/>
+          <a:p>
+            <a:pPr algn="l"/>
+            <a:r>
+              <a:rPr sz="3000" b="1">
+                <a:solidFill>
+                  <a:srgbClr val="132B33"/>
+                </a:solidFill>
+                <a:latin typeface="Aptos"/>
+              </a:rPr>
+              <a:t>Benchmark científico: o que é medido e o que não é</a:t>
+            </a:r>
+          </a:p>
+        </p:txBody>
+      </p:sp>
+      <p:sp>
+        <p:nvSpPr>
+          <p:cNvPr id="4" name="Rectangle 3"/>
+          <p:cNvSpPr/>
+          <p:nvPr/>
+        </p:nvSpPr>
+        <p:spPr>
+          <a:xfrm>
+            <a:off x="594360" y="1463040"/>
+            <a:ext cx="11018520" cy="25603"/>
+          </a:xfrm>
+          <a:prstGeom prst="rect">
+            <a:avLst/>
+          </a:prstGeom>
+          <a:solidFill>
+            <a:srgbClr val="B7914E"/>
+          </a:solidFill>
+          <a:ln>
+            <a:noFill/>
+          </a:ln>
+        </p:spPr>
+        <p:style>
+          <a:lnRef idx="1">
+            <a:schemeClr val="accent1"/>
+          </a:lnRef>
+          <a:fillRef idx="3">
+            <a:schemeClr val="accent1"/>
+          </a:fillRef>
+          <a:effectRef idx="2">
+            <a:schemeClr val="accent1"/>
+          </a:effectRef>
+          <a:fontRef idx="minor">
+            <a:schemeClr val="lt1"/>
+          </a:fontRef>
+        </p:style>
+        <p:txBody>
+          <a:bodyPr rtlCol="0" anchor="ctr"/>
+          <a:lstStyle/>
+          <a:p>
+            <a:pPr algn="ctr"/>
+          </a:p>
+        </p:txBody>
+      </p:sp>
+      <p:sp>
+        <p:nvSpPr>
+          <p:cNvPr id="5" name="TextBox 4"/>
+          <p:cNvSpPr txBox="1"/>
+          <p:nvPr/>
+        </p:nvSpPr>
+        <p:spPr>
+          <a:xfrm>
+            <a:off x="594360" y="6492240"/>
+            <a:ext cx="9144000" cy="228600"/>
+          </a:xfrm>
+          <a:prstGeom prst="rect">
+            <a:avLst/>
+          </a:prstGeom>
+          <a:noFill/>
+        </p:spPr>
+        <p:txBody>
+          <a:bodyPr wrap="square">
+            <a:spAutoFit/>
+          </a:bodyPr>
+          <a:lstStyle/>
+          <a:p>
+            <a:pPr algn="l"/>
+            <a:r>
+              <a:rPr sz="900" b="0">
+                <a:solidFill>
+                  <a:srgbClr val="54686B"/>
+                </a:solidFill>
+                <a:latin typeface="Aptos"/>
+              </a:rPr>
+              <a:t>REGISTROS DO FUNIL • DEFINIÇÕES PROVISÓRIAS • NÃO CAUSAL</a:t>
+            </a:r>
+          </a:p>
+        </p:txBody>
+      </p:sp>
+      <p:sp>
+        <p:nvSpPr>
+          <p:cNvPr id="6" name="TextBox 5"/>
+          <p:cNvSpPr txBox="1"/>
+          <p:nvPr/>
+        </p:nvSpPr>
+        <p:spPr>
+          <a:xfrm>
+            <a:off x="10972800" y="6455664"/>
+            <a:ext cx="731520" cy="274320"/>
+          </a:xfrm>
+          <a:prstGeom prst="rect">
+            <a:avLst/>
+          </a:prstGeom>
+          <a:noFill/>
+        </p:spPr>
+        <p:txBody>
+          <a:bodyPr wrap="square">
+            <a:spAutoFit/>
+          </a:bodyPr>
+          <a:lstStyle/>
+          <a:p>
+            <a:pPr algn="l"/>
+            <a:r>
+              <a:rPr sz="1100" b="1">
+                <a:solidFill>
+                  <a:srgbClr val="285F5B"/>
+                </a:solidFill>
+                <a:latin typeface="Aptos"/>
+              </a:rPr>
+              <a:t>25</a:t>
+            </a:r>
+          </a:p>
+        </p:txBody>
+      </p:sp>
+      <p:sp>
+        <p:nvSpPr>
+          <p:cNvPr id="7" name="TextBox 6"/>
+          <p:cNvSpPr txBox="1"/>
+          <p:nvPr/>
+        </p:nvSpPr>
+        <p:spPr>
+          <a:xfrm>
+            <a:off x="777240" y="1819656"/>
+            <a:ext cx="5029200" cy="365760"/>
+          </a:xfrm>
+          <a:prstGeom prst="rect">
+            <a:avLst/>
+          </a:prstGeom>
+          <a:noFill/>
+        </p:spPr>
+        <p:txBody>
+          <a:bodyPr wrap="square">
+            <a:spAutoFit/>
+          </a:bodyPr>
+          <a:lstStyle/>
+          <a:p>
+            <a:pPr algn="l"/>
+            <a:r>
+              <a:rPr sz="2100" b="1">
+                <a:solidFill>
+                  <a:srgbClr val="285F5B"/>
+                </a:solidFill>
+                <a:latin typeface="Aptos"/>
+              </a:rPr>
+              <a:t>Evidência disponível</a:t>
+            </a:r>
+          </a:p>
+        </p:txBody>
+      </p:sp>
+      <p:sp>
+        <p:nvSpPr>
+          <p:cNvPr id="8" name="TextBox 7"/>
+          <p:cNvSpPr txBox="1"/>
+          <p:nvPr/>
+        </p:nvSpPr>
+        <p:spPr>
+          <a:xfrm>
+            <a:off x="777240" y="2368296"/>
+            <a:ext cx="4846320" cy="1051560"/>
+          </a:xfrm>
+          <a:prstGeom prst="rect">
+            <a:avLst/>
+          </a:prstGeom>
+          <a:noFill/>
+        </p:spPr>
+        <p:txBody>
+          <a:bodyPr wrap="square">
+            <a:spAutoFit/>
+          </a:bodyPr>
+          <a:lstStyle/>
+          <a:p>
+            <a:pPr algn="l"/>
+            <a:r>
+              <a:rPr sz="1600" b="0">
+                <a:solidFill>
+                  <a:srgbClr val="132B33"/>
+                </a:solidFill>
+                <a:latin typeface="Aptos"/>
+              </a:rPr>
+              <a:t>Transições contratuais, Δ valor observado, estratos, cenários de casos abertos e incerteza agrupada.</a:t>
+            </a:r>
+          </a:p>
+        </p:txBody>
+      </p:sp>
+      <p:sp>
+        <p:nvSpPr>
+          <p:cNvPr id="9" name="TextBox 8"/>
+          <p:cNvSpPr txBox="1"/>
+          <p:nvPr/>
+        </p:nvSpPr>
+        <p:spPr>
+          <a:xfrm>
+            <a:off x="6355079" y="1819656"/>
+            <a:ext cx="5029200" cy="365760"/>
+          </a:xfrm>
+          <a:prstGeom prst="rect">
+            <a:avLst/>
+          </a:prstGeom>
+          <a:noFill/>
+        </p:spPr>
+        <p:txBody>
+          <a:bodyPr wrap="square">
+            <a:spAutoFit/>
+          </a:bodyPr>
+          <a:lstStyle/>
+          <a:p>
+            <a:pPr algn="l"/>
+            <a:r>
+              <a:rPr sz="2100" b="1">
+                <a:solidFill>
+                  <a:srgbClr val="285F5B"/>
+                </a:solidFill>
+                <a:latin typeface="Aptos"/>
+              </a:rPr>
+              <a:t>Lucro orientado à decisão</a:t>
+            </a:r>
+          </a:p>
+        </p:txBody>
+      </p:sp>
+      <p:sp>
+        <p:nvSpPr>
+          <p:cNvPr id="10" name="TextBox 9"/>
+          <p:cNvSpPr txBox="1"/>
+          <p:nvPr/>
+        </p:nvSpPr>
+        <p:spPr>
+          <a:xfrm>
+            <a:off x="6355079" y="2368296"/>
+            <a:ext cx="4846320" cy="1051560"/>
+          </a:xfrm>
+          <a:prstGeom prst="rect">
+            <a:avLst/>
+          </a:prstGeom>
+          <a:noFill/>
+        </p:spPr>
+        <p:txBody>
+          <a:bodyPr wrap="square">
+            <a:spAutoFit/>
+          </a:bodyPr>
+          <a:lstStyle/>
+          <a:p>
+            <a:pPr algn="l"/>
+            <a:r>
+              <a:rPr sz="1600" b="0">
+                <a:solidFill>
+                  <a:srgbClr val="132B33"/>
+                </a:solidFill>
+                <a:latin typeface="Aptos"/>
+              </a:rPr>
+              <a:t>Limiar paramétrico: uplift mínimo = custo por ação / contribuição marginal do sucesso. Parâmetros não observados.</a:t>
+            </a:r>
+          </a:p>
+        </p:txBody>
+      </p:sp>
+      <p:sp>
+        <p:nvSpPr>
+          <p:cNvPr id="11" name="TextBox 10"/>
+          <p:cNvSpPr txBox="1"/>
+          <p:nvPr/>
+        </p:nvSpPr>
+        <p:spPr>
+          <a:xfrm>
+            <a:off x="777240" y="3785615"/>
+            <a:ext cx="5029200" cy="365760"/>
+          </a:xfrm>
+          <a:prstGeom prst="rect">
+            <a:avLst/>
+          </a:prstGeom>
+          <a:noFill/>
+        </p:spPr>
+        <p:txBody>
+          <a:bodyPr wrap="square">
+            <a:spAutoFit/>
+          </a:bodyPr>
+          <a:lstStyle/>
+          <a:p>
+            <a:pPr algn="l"/>
+            <a:r>
+              <a:rPr sz="2100" b="1">
+                <a:solidFill>
+                  <a:srgbClr val="285F5B"/>
+                </a:solidFill>
+                <a:latin typeface="Aptos"/>
+              </a:rPr>
+              <a:t>Uplift causal</a:t>
+            </a:r>
+          </a:p>
+        </p:txBody>
+      </p:sp>
+      <p:sp>
+        <p:nvSpPr>
+          <p:cNvPr id="12" name="TextBox 11"/>
+          <p:cNvSpPr txBox="1"/>
+          <p:nvPr/>
+        </p:nvSpPr>
+        <p:spPr>
+          <a:xfrm>
+            <a:off x="777240" y="4334255"/>
+            <a:ext cx="4846320" cy="1051560"/>
+          </a:xfrm>
+          <a:prstGeom prst="rect">
+            <a:avLst/>
+          </a:prstGeom>
+          <a:noFill/>
+        </p:spPr>
+        <p:txBody>
+          <a:bodyPr wrap="square">
+            <a:spAutoFit/>
+          </a:bodyPr>
+          <a:lstStyle/>
+          <a:p>
+            <a:pPr algn="l"/>
+            <a:r>
+              <a:rPr sz="1600" b="0">
+                <a:solidFill>
+                  <a:srgbClr val="132B33"/>
+                </a:solidFill>
+                <a:latin typeface="Aptos"/>
+              </a:rPr>
+              <a:t>Sem oferta designada, grupo comparável ou aceite observado. Não estimar efeitos de intervenção.</a:t>
+            </a:r>
+          </a:p>
+        </p:txBody>
+      </p:sp>
+      <p:sp>
+        <p:nvSpPr>
+          <p:cNvPr id="13" name="TextBox 12"/>
+          <p:cNvSpPr txBox="1"/>
+          <p:nvPr/>
+        </p:nvSpPr>
+        <p:spPr>
+          <a:xfrm>
+            <a:off x="6355079" y="3785615"/>
+            <a:ext cx="5029200" cy="365760"/>
+          </a:xfrm>
+          <a:prstGeom prst="rect">
+            <a:avLst/>
+          </a:prstGeom>
+          <a:noFill/>
+        </p:spPr>
+        <p:txBody>
+          <a:bodyPr wrap="square">
+            <a:spAutoFit/>
+          </a:bodyPr>
+          <a:lstStyle/>
+          <a:p>
+            <a:pPr algn="l"/>
+            <a:r>
+              <a:rPr sz="2100" b="1">
+                <a:solidFill>
+                  <a:srgbClr val="285F5B"/>
+                </a:solidFill>
+                <a:latin typeface="Aptos"/>
+              </a:rPr>
+              <a:t>Sobrevivência</a:t>
+            </a:r>
+          </a:p>
+        </p:txBody>
+      </p:sp>
+      <p:sp>
+        <p:nvSpPr>
+          <p:cNvPr id="14" name="TextBox 13"/>
+          <p:cNvSpPr txBox="1"/>
+          <p:nvPr/>
+        </p:nvSpPr>
+        <p:spPr>
+          <a:xfrm>
+            <a:off x="6355079" y="4334255"/>
+            <a:ext cx="4846320" cy="1051560"/>
+          </a:xfrm>
+          <a:prstGeom prst="rect">
+            <a:avLst/>
+          </a:prstGeom>
+          <a:noFill/>
+        </p:spPr>
+        <p:txBody>
+          <a:bodyPr wrap="square">
+            <a:spAutoFit/>
+          </a:bodyPr>
+          <a:lstStyle/>
+          <a:p>
+            <a:pPr algn="l"/>
+            <a:r>
+              <a:rPr sz="1600" b="0">
+                <a:solidFill>
+                  <a:srgbClr val="132B33"/>
+                </a:solidFill>
+                <a:latin typeface="Aptos"/>
+              </a:rPr>
+              <a:t>Sem data do evento e censura individual. Usar limites por casos em aberto; não ajustar modelos de tempo até evento.</a:t>
+            </a:r>
+          </a:p>
+        </p:txBody>
+      </p:sp>
+    </p:spTree>
+  </p:cSld>
+  <p:clrMapOvr>
+    <a:masterClrMapping/>
+  </p:clrMapOvr>
+</p:sld>
+</file>
+
 <file path=ppt/slides/slide3.xml><?xml version="1.0" encoding="utf-8"?>
 <p:sld xmlns:a="http://schemas.openxmlformats.org/drawingml/2006/main" xmlns:r="http://schemas.openxmlformats.org/officeDocument/2006/relationships" xmlns:p="http://schemas.openxmlformats.org/presentationml/2006/main">
   <p:cSld name="Slide 3">

</xml_diff>

<commit_message>
fix: present MPlay movement rates on a common denominator
</commit_message>
<xml_diff>
--- a/presentations/Case_Retencao_Resultados_e_Descobertas_2025.pptx
+++ b/presentations/Case_Retencao_Resultados_e_Descobertas_2025.pptx
@@ -795,12 +795,20 @@
           <a:lstStyle/>
           <a:p>
             <a:r>
-              <a:rPr lang="en-US" dirty="0"/>
-              <a:t>MPlay distingue perfis, mas 93% dos retidos não têm classificação
-A variável de consolidação de faturas é interessante do ponto de vista comercial: os grupos MARCADO e NÃO MARCADO têm taxas de movimentação bastante distintas. Entretanto, 232.017 dos registros retidos não trazem classificação informada, cerca de 93,1 por cento. Isso pode refletir ausência estrutural de elegibilidade; não podemos imputar comportamento nem atribuir efeito causal à unificação.
-Transição: Na comparação dos canais, também é necessário separar comportamento e composição.</a:t>
-            </a:r>
-            <a:endParaRPr lang="en-US" dirty="0"/>
+              <a:t>A situação MPlay está associada a taxas distintas de movimentação</a:t>
+            </a:r>
+          </a:p>
+          <a:p/>
+          <a:p>
+            <a:r>
+              <a:t>O enunciado define três situações em M0: MARCADO significa faturas residencial e móvel unificadas; NÃO MARCADO significa elegível à unificação; campo vazio significa NÃO ELEGÍVEL. Entre registros classificados como RETIDO, 10.587 com faturas unificadas apresentaram taxa de movimentação de 54,0%; 6.705 elegíveis tiveram taxa de 15,2%; 232.017 não elegíveis tiveram taxa de 34,4%. O último grupo equivale a 93,1% dos retidos. Não se deve comparar o percentual de tamanho da população com as taxas de movimentação. Nenhuma diferença representa um efeito causal da unificação.</a:t>
+            </a:r>
+          </a:p>
+          <a:p/>
+          <a:p>
+            <a:r>
+              <a:t>Transição: A composição da carteira e a origem do atendimento também diferenciam as frequências observadas.</a:t>
+            </a:r>
           </a:p>
         </p:txBody>
       </p:sp>
@@ -6038,6 +6046,10 @@
             <a:prstDash val="solid"/>
           </a:ln>
         </p:spPr>
+        <p:txBody>
+          <a:bodyPr/>
+          <a:p/>
+        </p:txBody>
       </p:sp>
       <p:sp>
         <p:nvSpPr>
@@ -6111,7 +6123,7 @@
                 <a:ea typeface="Aptos" pitchFamily="34" charset="-122"/>
                 <a:cs typeface="Aptos" pitchFamily="34" charset="-120"/>
               </a:rPr>
-              <a:t>MPlay distingue perfis, mas 93% dos retidos não têm classificação</a:t>
+              <a:t>A situação MPlay está associada a taxas distintas de movimentação</a:t>
             </a:r>
             <a:endParaRPr lang="en-US" sz="2940" dirty="0"/>
           </a:p>
@@ -6139,6 +6151,10 @@
             <a:prstDash val="solid"/>
           </a:ln>
         </p:spPr>
+        <p:txBody>
+          <a:bodyPr/>
+          <a:p/>
+        </p:txBody>
       </p:sp>
       <p:sp>
         <p:nvSpPr>
@@ -6244,6 +6260,10 @@
             <a:prstDash val="solid"/>
           </a:ln>
         </p:spPr>
+        <p:txBody>
+          <a:bodyPr/>
+          <a:p/>
+        </p:txBody>
       </p:sp>
       <p:sp>
         <p:nvSpPr>
@@ -6273,6 +6293,10 @@
             <a:prstDash val="solid"/>
           </a:ln>
         </p:spPr>
+        <p:txBody>
+          <a:bodyPr/>
+          <a:p/>
+        </p:txBody>
       </p:sp>
       <p:sp>
         <p:nvSpPr>
@@ -6307,7 +6331,7 @@
                 <a:ea typeface="Aptos" pitchFamily="34" charset="-122"/>
                 <a:cs typeface="Aptos" pitchFamily="34" charset="-120"/>
               </a:rPr>
-              <a:t>MPLAY MARCADO</a:t>
+              <a:t>FATURAS UNIFICADAS</a:t>
             </a:r>
             <a:endParaRPr lang="en-US" sz="950" dirty="0"/>
           </a:p>
@@ -6417,6 +6441,10 @@
             <a:prstDash val="solid"/>
           </a:ln>
         </p:spPr>
+        <p:txBody>
+          <a:bodyPr/>
+          <a:p/>
+        </p:txBody>
       </p:sp>
       <p:sp>
         <p:nvSpPr>
@@ -6446,6 +6474,10 @@
             <a:prstDash val="solid"/>
           </a:ln>
         </p:spPr>
+        <p:txBody>
+          <a:bodyPr/>
+          <a:p/>
+        </p:txBody>
       </p:sp>
       <p:sp>
         <p:nvSpPr>
@@ -6480,7 +6512,7 @@
                 <a:ea typeface="Aptos" pitchFamily="34" charset="-122"/>
                 <a:cs typeface="Aptos" pitchFamily="34" charset="-120"/>
               </a:rPr>
-              <a:t>NÃO MARCADO</a:t>
+              <a:t>ELEGÍVEL À UNIFICAÇÃO</a:t>
             </a:r>
             <a:endParaRPr lang="en-US" sz="950" dirty="0"/>
           </a:p>
@@ -6590,6 +6622,10 @@
             <a:prstDash val="solid"/>
           </a:ln>
         </p:spPr>
+        <p:txBody>
+          <a:bodyPr/>
+          <a:p/>
+        </p:txBody>
       </p:sp>
       <p:sp>
         <p:nvSpPr>
@@ -6619,6 +6655,10 @@
             <a:prstDash val="solid"/>
           </a:ln>
         </p:spPr>
+        <p:txBody>
+          <a:bodyPr/>
+          <a:p/>
+        </p:txBody>
       </p:sp>
       <p:sp>
         <p:nvSpPr>
@@ -6653,7 +6693,7 @@
                 <a:ea typeface="Aptos" pitchFamily="34" charset="-122"/>
                 <a:cs typeface="Aptos" pitchFamily="34" charset="-120"/>
               </a:rPr>
-              <a:t>SEM VALOR INFORMADO</a:t>
+              <a:t>NÃO ELEGÍVEL</a:t>
             </a:r>
             <a:endParaRPr lang="en-US" sz="950" dirty="0"/>
           </a:p>
@@ -6692,7 +6732,7 @@
                 <a:ea typeface="Aptos" pitchFamily="34" charset="-122"/>
                 <a:cs typeface="Aptos" pitchFamily="34" charset="-120"/>
               </a:rPr>
-              <a:t>93,1%</a:t>
+              <a:t>34,4%</a:t>
             </a:r>
             <a:endParaRPr lang="en-US" sz="3000" dirty="0"/>
           </a:p>
@@ -6770,7 +6810,7 @@
                 <a:ea typeface="Aptos" pitchFamily="34" charset="-122"/>
                 <a:cs typeface="Aptos" pitchFamily="34" charset="-120"/>
               </a:rPr>
-              <a:t>Diferenças observadas não podem ser atribuídas à unificação de faturas sem esclarecer elegibilidade e preenchimento.</a:t>
+              <a:t>O grupo não elegível reúne 93,1% dos retidos. Os percentuais dos três grupos são taxas de movimentação, não efeitos causais.</a:t>
             </a:r>
             <a:endParaRPr lang="en-US" sz="1800" dirty="0"/>
           </a:p>

</xml_diff>

<commit_message>
fix: present MPlay movement rates on a common denominator (#16)
</commit_message>
<xml_diff>
--- a/presentations/Case_Retencao_Resultados_e_Descobertas_2025.pptx
+++ b/presentations/Case_Retencao_Resultados_e_Descobertas_2025.pptx
@@ -795,12 +795,20 @@
           <a:lstStyle/>
           <a:p>
             <a:r>
-              <a:rPr lang="en-US" dirty="0"/>
-              <a:t>MPlay distingue perfis, mas 93% dos retidos não têm classificação
-A variável de consolidação de faturas é interessante do ponto de vista comercial: os grupos MARCADO e NÃO MARCADO têm taxas de movimentação bastante distintas. Entretanto, 232.017 dos registros retidos não trazem classificação informada, cerca de 93,1 por cento. Isso pode refletir ausência estrutural de elegibilidade; não podemos imputar comportamento nem atribuir efeito causal à unificação.
-Transição: Na comparação dos canais, também é necessário separar comportamento e composição.</a:t>
-            </a:r>
-            <a:endParaRPr lang="en-US" dirty="0"/>
+              <a:t>A situação MPlay está associada a taxas distintas de movimentação</a:t>
+            </a:r>
+          </a:p>
+          <a:p/>
+          <a:p>
+            <a:r>
+              <a:t>O enunciado define três situações em M0: MARCADO significa faturas residencial e móvel unificadas; NÃO MARCADO significa elegível à unificação; campo vazio significa NÃO ELEGÍVEL. Entre registros classificados como RETIDO, 10.587 com faturas unificadas apresentaram taxa de movimentação de 54,0%; 6.705 elegíveis tiveram taxa de 15,2%; 232.017 não elegíveis tiveram taxa de 34,4%. O último grupo equivale a 93,1% dos retidos. Não se deve comparar o percentual de tamanho da população com as taxas de movimentação. Nenhuma diferença representa um efeito causal da unificação.</a:t>
+            </a:r>
+          </a:p>
+          <a:p/>
+          <a:p>
+            <a:r>
+              <a:t>Transição: A composição da carteira e a origem do atendimento também diferenciam as frequências observadas.</a:t>
+            </a:r>
           </a:p>
         </p:txBody>
       </p:sp>
@@ -6038,6 +6046,10 @@
             <a:prstDash val="solid"/>
           </a:ln>
         </p:spPr>
+        <p:txBody>
+          <a:bodyPr/>
+          <a:p/>
+        </p:txBody>
       </p:sp>
       <p:sp>
         <p:nvSpPr>
@@ -6111,7 +6123,7 @@
                 <a:ea typeface="Aptos" pitchFamily="34" charset="-122"/>
                 <a:cs typeface="Aptos" pitchFamily="34" charset="-120"/>
               </a:rPr>
-              <a:t>MPlay distingue perfis, mas 93% dos retidos não têm classificação</a:t>
+              <a:t>A situação MPlay está associada a taxas distintas de movimentação</a:t>
             </a:r>
             <a:endParaRPr lang="en-US" sz="2940" dirty="0"/>
           </a:p>
@@ -6139,6 +6151,10 @@
             <a:prstDash val="solid"/>
           </a:ln>
         </p:spPr>
+        <p:txBody>
+          <a:bodyPr/>
+          <a:p/>
+        </p:txBody>
       </p:sp>
       <p:sp>
         <p:nvSpPr>
@@ -6244,6 +6260,10 @@
             <a:prstDash val="solid"/>
           </a:ln>
         </p:spPr>
+        <p:txBody>
+          <a:bodyPr/>
+          <a:p/>
+        </p:txBody>
       </p:sp>
       <p:sp>
         <p:nvSpPr>
@@ -6273,6 +6293,10 @@
             <a:prstDash val="solid"/>
           </a:ln>
         </p:spPr>
+        <p:txBody>
+          <a:bodyPr/>
+          <a:p/>
+        </p:txBody>
       </p:sp>
       <p:sp>
         <p:nvSpPr>
@@ -6307,7 +6331,7 @@
                 <a:ea typeface="Aptos" pitchFamily="34" charset="-122"/>
                 <a:cs typeface="Aptos" pitchFamily="34" charset="-120"/>
               </a:rPr>
-              <a:t>MPLAY MARCADO</a:t>
+              <a:t>FATURAS UNIFICADAS</a:t>
             </a:r>
             <a:endParaRPr lang="en-US" sz="950" dirty="0"/>
           </a:p>
@@ -6417,6 +6441,10 @@
             <a:prstDash val="solid"/>
           </a:ln>
         </p:spPr>
+        <p:txBody>
+          <a:bodyPr/>
+          <a:p/>
+        </p:txBody>
       </p:sp>
       <p:sp>
         <p:nvSpPr>
@@ -6446,6 +6474,10 @@
             <a:prstDash val="solid"/>
           </a:ln>
         </p:spPr>
+        <p:txBody>
+          <a:bodyPr/>
+          <a:p/>
+        </p:txBody>
       </p:sp>
       <p:sp>
         <p:nvSpPr>
@@ -6480,7 +6512,7 @@
                 <a:ea typeface="Aptos" pitchFamily="34" charset="-122"/>
                 <a:cs typeface="Aptos" pitchFamily="34" charset="-120"/>
               </a:rPr>
-              <a:t>NÃO MARCADO</a:t>
+              <a:t>ELEGÍVEL À UNIFICAÇÃO</a:t>
             </a:r>
             <a:endParaRPr lang="en-US" sz="950" dirty="0"/>
           </a:p>
@@ -6590,6 +6622,10 @@
             <a:prstDash val="solid"/>
           </a:ln>
         </p:spPr>
+        <p:txBody>
+          <a:bodyPr/>
+          <a:p/>
+        </p:txBody>
       </p:sp>
       <p:sp>
         <p:nvSpPr>
@@ -6619,6 +6655,10 @@
             <a:prstDash val="solid"/>
           </a:ln>
         </p:spPr>
+        <p:txBody>
+          <a:bodyPr/>
+          <a:p/>
+        </p:txBody>
       </p:sp>
       <p:sp>
         <p:nvSpPr>
@@ -6653,7 +6693,7 @@
                 <a:ea typeface="Aptos" pitchFamily="34" charset="-122"/>
                 <a:cs typeface="Aptos" pitchFamily="34" charset="-120"/>
               </a:rPr>
-              <a:t>SEM VALOR INFORMADO</a:t>
+              <a:t>NÃO ELEGÍVEL</a:t>
             </a:r>
             <a:endParaRPr lang="en-US" sz="950" dirty="0"/>
           </a:p>
@@ -6692,7 +6732,7 @@
                 <a:ea typeface="Aptos" pitchFamily="34" charset="-122"/>
                 <a:cs typeface="Aptos" pitchFamily="34" charset="-120"/>
               </a:rPr>
-              <a:t>93,1%</a:t>
+              <a:t>34,4%</a:t>
             </a:r>
             <a:endParaRPr lang="en-US" sz="3000" dirty="0"/>
           </a:p>
@@ -6770,7 +6810,7 @@
                 <a:ea typeface="Aptos" pitchFamily="34" charset="-122"/>
                 <a:cs typeface="Aptos" pitchFamily="34" charset="-120"/>
               </a:rPr>
-              <a:t>Diferenças observadas não podem ser atribuídas à unificação de faturas sem esclarecer elegibilidade e preenchimento.</a:t>
+              <a:t>O grupo não elegível reúne 93,1% dos retidos. Os percentuais dos três grupos são taxas de movimentação, não efeitos causais.</a:t>
             </a:r>
             <a:endParaRPr lang="en-US" sz="1800" dirty="0"/>
           </a:p>

</xml_diff>